<commit_message>
Close the reference slide on delivery time
All three systems went live in days or weeks. That is the strongest claim
available on this slide and it was nowhere on it — the closing line restated the
pipeline instead, which the three cards above already demonstrate.

The line now ends on the time, with the accent on it, so the eye lands there
last. It also sets up the twelve-weeks question at the end of the deck: the
reference slide earns the number the closing slide asks the audience to imagine.

Co-Authored-By: Claude Opus 5 <noreply@anthropic.com>
Claude-Session: https://claude.ai/code/session_01F4vsvBCtTptziT9dDHSPcr
</commit_message>
<xml_diff>
--- a/decks/Pitch_Deck_AthenaRun_v4.5.pptx
+++ b/decks/Pitch_Deck_AthenaRun_v4.5.pptx
@@ -51747,7 +51747,25 @@
                 </a:solidFill>
                 <a:latin typeface="Poppins"/>
               </a:rPr>
-              <a:t>Three sectors, one chain. The same pipeline produced all three.</a:t>
+              <a:t>Three sectors, one chain. Every one of them live in </a:t>
+            </a:r>
+            <a:r>
+              <a:rPr sz="1400" b="1">
+                <a:solidFill>
+                  <a:srgbClr val="FF6B3D"/>
+                </a:solidFill>
+                <a:latin typeface="Poppins"/>
+              </a:rPr>
+              <a:t>days or weeks</a:t>
+            </a:r>
+            <a:r>
+              <a:rPr sz="1400" b="1">
+                <a:solidFill>
+                  <a:srgbClr val="ECECEE"/>
+                </a:solidFill>
+                <a:latin typeface="Poppins"/>
+              </a:rPr>
+              <a:t>.</a:t>
             </a:r>
           </a:p>
         </p:txBody>

</xml_diff>

<commit_message>
Put both figures on slide 4 on one baseline
The 61 box was still dimensioned for the 120pt it used to hold, so after the
type audit dropped the figure to 54pt it floated half an inch below the 50 it
is meant to be read against, and the rule beneath it sat an inch lower than the
right column's. Matching the right box's height aligns the two numbers and lets
both rules land on 3.90.

Co-Authored-By: Claude Opus 5 <noreply@anthropic.com>
Claude-Session: https://claude.ai/code/session_01F4vsvBCtTptziT9dDHSPcr
</commit_message>
<xml_diff>
--- a/decks/Pitch_Deck_AthenaRun_v4.5.pptx
+++ b/decks/Pitch_Deck_AthenaRun_v4.5.pptx
@@ -45373,7 +45373,7 @@
         <p:spPr>
           <a:xfrm>
             <a:off x="694944" y="2688336"/>
-            <a:ext cx="5029200" cy="1700784"/>
+            <a:ext cx="5029200" cy="694944"/>
           </a:xfrm>
           <a:prstGeom prst="rect">
             <a:avLst/>
@@ -45442,7 +45442,7 @@
         </p:nvSpPr>
         <p:spPr>
           <a:xfrm>
-            <a:off x="694944" y="4443984"/>
+            <a:off x="694944" y="3566160"/>
             <a:ext cx="5029200" cy="11101"/>
           </a:xfrm>
           <a:prstGeom prst="rect">

</xml_diff>